<commit_message>
Costa Rica desde 2016: la serie cubre el quiebre exportador de 2019
</commit_message>
<xml_diff>
--- a/Presentacion_CID_IA_Sectores.pptx
+++ b/Presentacion_CID_IA_Sectores.pptx
@@ -3340,7 +3340,7 @@
                 </a:solidFill>
                 <a:latin typeface="Calibri"/>
               </a:rPr>
-              <a:t>6 encuestas de empleo  ·  2,5 millones de anuncios de trabajo  ·  2021–2026</a:t>
+              <a:t>6 encuestas de empleo  ·  2,5 millones de anuncios de trabajo  ·  2015–2026</a:t>
             </a:r>
           </a:p>
         </p:txBody>
@@ -4973,8 +4973,8 @@
         </p:blipFill>
         <p:spPr>
           <a:xfrm>
-            <a:off x="1743789" y="1737360"/>
-            <a:ext cx="8704117" cy="3931920"/>
+            <a:off x="1737365" y="1737360"/>
+            <a:ext cx="8716965" cy="3931920"/>
           </a:xfrm>
           <a:prstGeom prst="rect">
             <a:avLst/>
@@ -5018,7 +5018,7 @@
                 </a:solidFill>
                 <a:latin typeface="Calibri"/>
               </a:rPr>
-              <a:t>Izquierda: los dos países cuya encuesta permite seguir el sector año a año. Derecha: los cinco países con anuncios, sobre el total de su economía, porque la base no permite separar los sectores.</a:t>
+              <a:t>Izquierda: los dos países cuya encuesta permite seguir el sector año a año; Costa Rica desde 2016, porque su encuesta previa a la pandemia sí está en el kit. En 2020 no hubo encuesta. Derecha: los cinco países con anuncios, sobre el total de su economía, porque la base no permite separar los sectores.</a:t>
             </a:r>
           </a:p>
         </p:txBody>
@@ -5377,15 +5377,57 @@
           </a:p>
         </p:txBody>
       </p:sp>
+      <p:sp>
+        <p:nvSpPr>
+          <p:cNvPr id="10" name="TextBox 9"/>
+          <p:cNvSpPr txBox="1"/>
+          <p:nvPr/>
+        </p:nvSpPr>
+        <p:spPr>
+          <a:xfrm>
+            <a:off x="658368" y="3749039"/>
+            <a:ext cx="10881360" cy="457200"/>
+          </a:xfrm>
+          <a:prstGeom prst="rect">
+            <a:avLst/>
+          </a:prstGeom>
+          <a:noFill/>
+        </p:spPr>
+        <p:txBody>
+          <a:bodyPr wrap="square" lIns="0" rIns="0" tIns="0" bIns="0">
+            <a:spAutoFit/>
+          </a:bodyPr>
+          <a:lstStyle/>
+          <a:p>
+            <a:pPr algn="l">
+              <a:lnSpc>
+                <a:spcPct val="125000"/>
+              </a:lnSpc>
+              <a:spcAft>
+                <a:spcPts val="600"/>
+              </a:spcAft>
+            </a:pPr>
+            <a:r>
+              <a:rPr sz="1400" b="0">
+                <a:solidFill>
+                  <a:srgbClr val="6B6A64"/>
+                </a:solidFill>
+                <a:latin typeface="Calibri"/>
+              </a:rPr>
+              <a:t>Costa Rica permite mirar una década entera: entre 2016 y 2024 el empleo del sector se duplicó, y la proporción de técnicos y profesionales pasó de 31% antes de la pandemia a 27% después. No subió en ningún tramo.</a:t>
+            </a:r>
+          </a:p>
+        </p:txBody>
+      </p:sp>
       <p:cxnSp>
         <p:nvCxnSpPr>
-          <p:cNvPr id="10" name="Connector 9"/>
+          <p:cNvPr id="11" name="Connector 10"/>
           <p:cNvCxnSpPr/>
           <p:nvPr/>
         </p:nvCxnSpPr>
         <p:spPr>
           <a:xfrm>
-            <a:off x="658368" y="4343400"/>
+            <a:off x="658368" y="4590288"/>
             <a:ext cx="10874959" cy="0"/>
           </a:xfrm>
           <a:prstGeom prst="line">
@@ -5414,13 +5456,13 @@
       </p:cxnSp>
       <p:sp>
         <p:nvSpPr>
-          <p:cNvPr id="11" name="TextBox 10"/>
+          <p:cNvPr id="12" name="TextBox 11"/>
           <p:cNvSpPr txBox="1"/>
           <p:nvPr/>
         </p:nvSpPr>
         <p:spPr>
           <a:xfrm>
-            <a:off x="658368" y="4617720"/>
+            <a:off x="658368" y="4846320"/>
             <a:ext cx="10881360" cy="1463040"/>
           </a:xfrm>
           <a:prstGeom prst="rect">
@@ -5456,13 +5498,13 @@
       </p:sp>
       <p:sp>
         <p:nvSpPr>
-          <p:cNvPr id="12" name="TextBox 11"/>
+          <p:cNvPr id="13" name="TextBox 12"/>
           <p:cNvSpPr txBox="1"/>
           <p:nvPr/>
         </p:nvSpPr>
         <p:spPr>
           <a:xfrm>
-            <a:off x="658368" y="5897880"/>
+            <a:off x="658368" y="6053328"/>
             <a:ext cx="10881360" cy="548640"/>
           </a:xfrm>
           <a:prstGeom prst="rect">
@@ -8078,7 +8120,7 @@
                         </a:defRPr>
                       </a:pPr>
                       <a:r>
-                        <a:t>2021–2025</a:t>
+                        <a:t>2016–2025</a:t>
                       </a:r>
                     </a:p>
                   </a:txBody>

</xml_diff>

<commit_message>
Cobertura: se explica por que Guatemala no entra en los cortes finos
</commit_message>
<xml_diff>
--- a/Presentacion_CID_IA_Sectores.pptx
+++ b/Presentacion_CID_IA_Sectores.pptx
@@ -8841,14 +8841,14 @@
           <a:p>
             <a:pPr algn="l">
               <a:lnSpc>
-                <a:spcPct val="130000"/>
-              </a:lnSpc>
-              <a:spcAft>
-                <a:spcPts val="600"/>
-              </a:spcAft>
-            </a:pPr>
-            <a:r>
-              <a:rPr sz="1300" b="0">
+                <a:spcPct val="125000"/>
+              </a:lnSpc>
+              <a:spcAft>
+                <a:spcPts val="600"/>
+              </a:spcAft>
+            </a:pPr>
+            <a:r>
+              <a:rPr sz="1250" b="0">
                 <a:solidFill>
                   <a:srgbClr val="1C1C1A"/>
                 </a:solidFill>
@@ -8860,14 +8860,14 @@
           <a:p>
             <a:pPr algn="l">
               <a:lnSpc>
-                <a:spcPct val="130000"/>
-              </a:lnSpc>
-              <a:spcAft>
-                <a:spcPts val="600"/>
-              </a:spcAft>
-            </a:pPr>
-            <a:r>
-              <a:rPr sz="1300" b="0">
+                <a:spcPct val="125000"/>
+              </a:lnSpc>
+              <a:spcAft>
+                <a:spcPts val="600"/>
+              </a:spcAft>
+            </a:pPr>
+            <a:r>
+              <a:rPr sz="1250" b="0">
                 <a:solidFill>
                   <a:srgbClr val="1C1C1A"/>
                 </a:solidFill>
@@ -8879,14 +8879,14 @@
           <a:p>
             <a:pPr algn="l">
               <a:lnSpc>
-                <a:spcPct val="130000"/>
-              </a:lnSpc>
-              <a:spcAft>
-                <a:spcPts val="600"/>
-              </a:spcAft>
-            </a:pPr>
-            <a:r>
-              <a:rPr sz="1300" b="0">
+                <a:spcPct val="125000"/>
+              </a:lnSpc>
+              <a:spcAft>
+                <a:spcPts val="600"/>
+              </a:spcAft>
+            </a:pPr>
+            <a:r>
+              <a:rPr sz="1250" b="0">
                 <a:solidFill>
                   <a:srgbClr val="1C1C1A"/>
                 </a:solidFill>
@@ -8898,14 +8898,14 @@
           <a:p>
             <a:pPr algn="l">
               <a:lnSpc>
-                <a:spcPct val="130000"/>
-              </a:lnSpc>
-              <a:spcAft>
-                <a:spcPts val="600"/>
-              </a:spcAft>
-            </a:pPr>
-            <a:r>
-              <a:rPr sz="1300" b="0">
+                <a:spcPct val="125000"/>
+              </a:lnSpc>
+              <a:spcAft>
+                <a:spcPts val="600"/>
+              </a:spcAft>
+            </a:pPr>
+            <a:r>
+              <a:rPr sz="1250" b="0">
                 <a:solidFill>
                   <a:srgbClr val="1C1C1A"/>
                 </a:solidFill>
@@ -8917,14 +8917,14 @@
           <a:p>
             <a:pPr algn="l">
               <a:lnSpc>
-                <a:spcPct val="130000"/>
-              </a:lnSpc>
-              <a:spcAft>
-                <a:spcPts val="600"/>
-              </a:spcAft>
-            </a:pPr>
-            <a:r>
-              <a:rPr sz="1300" b="0">
+                <a:spcPct val="125000"/>
+              </a:lnSpc>
+              <a:spcAft>
+                <a:spcPts val="600"/>
+              </a:spcAft>
+            </a:pPr>
+            <a:r>
+              <a:rPr sz="1250" b="0">
                 <a:solidFill>
                   <a:srgbClr val="1C1C1A"/>
                 </a:solidFill>
@@ -8936,14 +8936,14 @@
           <a:p>
             <a:pPr algn="l">
               <a:lnSpc>
-                <a:spcPct val="130000"/>
-              </a:lnSpc>
-              <a:spcAft>
-                <a:spcPts val="600"/>
-              </a:spcAft>
-            </a:pPr>
-            <a:r>
-              <a:rPr sz="1300" b="0">
+                <a:spcPct val="125000"/>
+              </a:lnSpc>
+              <a:spcAft>
+                <a:spcPts val="600"/>
+              </a:spcAft>
+            </a:pPr>
+            <a:r>
+              <a:rPr sz="1250" b="0">
                 <a:solidFill>
                   <a:srgbClr val="1C1C1A"/>
                 </a:solidFill>
@@ -8955,20 +8955,58 @@
           <a:p>
             <a:pPr algn="l">
               <a:lnSpc>
-                <a:spcPct val="130000"/>
-              </a:lnSpc>
-              <a:spcAft>
-                <a:spcPts val="600"/>
-              </a:spcAft>
-            </a:pPr>
-            <a:r>
-              <a:rPr sz="1300" b="0">
+                <a:spcPct val="125000"/>
+              </a:lnSpc>
+              <a:spcAft>
+                <a:spcPts val="600"/>
+              </a:spcAft>
+            </a:pPr>
+            <a:r>
+              <a:rPr sz="1250" b="0">
                 <a:solidFill>
                   <a:srgbClr val="1C1C1A"/>
                 </a:solidFill>
                 <a:latin typeface="Calibri"/>
               </a:rPr>
               <a:t>República Dominicana tiene dos cortes, no una serie.</a:t>
+            </a:r>
+          </a:p>
+          <a:p>
+            <a:pPr algn="l">
+              <a:lnSpc>
+                <a:spcPct val="125000"/>
+              </a:lnSpc>
+              <a:spcAft>
+                <a:spcPts val="600"/>
+              </a:spcAft>
+            </a:pPr>
+            <a:r>
+              <a:rPr sz="1250" b="0">
+                <a:solidFill>
+                  <a:srgbClr val="1C1C1A"/>
+                </a:solidFill>
+                <a:latin typeface="Calibri"/>
+              </a:rPr>
+              <a:t/>
+            </a:r>
+          </a:p>
+          <a:p>
+            <a:pPr algn="l">
+              <a:lnSpc>
+                <a:spcPct val="125000"/>
+              </a:lnSpc>
+              <a:spcAft>
+                <a:spcPts val="600"/>
+              </a:spcAft>
+            </a:pPr>
+            <a:r>
+              <a:rPr sz="1250" b="0">
+                <a:solidFill>
+                  <a:srgbClr val="1C1C1A"/>
+                </a:solidFill>
+                <a:latin typeface="Calibri"/>
+              </a:rPr>
+              <a:t>Guatemala publica sus datos sin el detalle de oficio ni de rama, así que no entra en los cortes finos. No se arregla con otra encuesta.</a:t>
             </a:r>
           </a:p>
         </p:txBody>

</xml_diff>

<commit_message>
Panama entra en las dos fuentes
</commit_message>
<xml_diff>
--- a/Presentacion_CID_IA_Sectores.pptx
+++ b/Presentacion_CID_IA_Sectores.pptx
@@ -3341,7 +3341,7 @@
                 </a:solidFill>
                 <a:latin typeface="Calibri"/>
               </a:rPr>
-              <a:t>6 encuestas de empleo  ·  2,5 millones de anuncios de trabajo  ·  2015–2026</a:t>
+              <a:t>7 encuestas de empleo  ·  2,8 millones de anuncios de trabajo  ·  2015–2026</a:t>
             </a:r>
           </a:p>
         </p:txBody>
@@ -4698,7 +4698,7 @@
                 </a:solidFill>
                 <a:latin typeface="Calibri"/>
               </a:rPr>
-              <a:t>925 mil anuncios de CAPARD (Guatemala, Honduras, Costa Rica y República Dominicana) y 1,6 millones de México. El Salvador, Nicaragua y Panamá no tienen anuncios en la base.</a:t>
+              <a:t>1,1 millones de anuncios de CAPARD (Guatemala, Honduras, Costa Rica, Panamá y República Dominicana) y 1,6 millones de México. El Salvador, Nicaragua y Panamá no tienen anuncios en la base.</a:t>
             </a:r>
           </a:p>
         </p:txBody>
@@ -7824,7 +7824,7 @@
                 </a:solidFill>
                 <a:latin typeface="Calibri"/>
               </a:rPr>
-              <a:t>México (ENOE) · Costa Rica (ECE) · El Salvador (EHPM) · Honduras (EPHPM) · Guatemala (ENCOVI) · República Dominicana (ENCFT)</a:t>
+              <a:t>México (ENOE) · Costa Rica (ECE) · El Salvador (EHPM) · Honduras (EPHPM) · Guatemala (ENCOVI) · Panamá (EML) · República Dominicana (ENCFT)</a:t>
             </a:r>
           </a:p>
           <a:p>
@@ -7862,7 +7862,7 @@
                 </a:solidFill>
                 <a:latin typeface="Calibri"/>
               </a:rPr>
-              <a:t>No hay datos de Nicaragua ni de Panamá.</a:t>
+              <a:t>Nicaragua es el único país sin datos.</a:t>
             </a:r>
           </a:p>
         </p:txBody>
@@ -7984,7 +7984,7 @@
                 </a:solidFill>
                 <a:latin typeface="Calibri"/>
               </a:rPr>
-              <a:t>México · Guatemala · Honduras · Costa Rica · República Dominicana</a:t>
+              <a:t>México · Guatemala · Honduras · Costa Rica · Panamá · República Dominicana</a:t>
             </a:r>
           </a:p>
           <a:p>
@@ -8022,7 +8022,7 @@
                 </a:solidFill>
                 <a:latin typeface="Calibri"/>
               </a:rPr>
-              <a:t>El Salvador y Panamá no fueron entregados.</a:t>
+              <a:t>El Salvador no forma parte de la entrega.</a:t>
             </a:r>
           </a:p>
         </p:txBody>
@@ -8987,9 +8987,9 @@
                     <a:lstStyle/>
                     <a:p>
                       <a:pPr algn="l">
-                        <a:defRPr sz="1250" b="1">
+                        <a:defRPr sz="1250" b="0">
                           <a:solidFill>
-                            <a:srgbClr val="1C1C1A"/>
+                            <a:srgbClr val="6B6A64"/>
                           </a:solidFill>
                         </a:defRPr>
                       </a:pPr>
@@ -9008,14 +9008,14 @@
                     <a:lstStyle/>
                     <a:p>
                       <a:pPr algn="r">
-                        <a:defRPr sz="1250" b="1">
+                        <a:defRPr sz="1250" b="0">
                           <a:solidFill>
-                            <a:srgbClr val="1C1C1A"/>
+                            <a:srgbClr val="6B6A64"/>
                           </a:solidFill>
                         </a:defRPr>
                       </a:pPr>
                       <a:r>
-                        <a:t>sin datos</a:t>
+                        <a:t>EML</a:t>
                       </a:r>
                     </a:p>
                   </a:txBody>
@@ -9029,14 +9029,14 @@
                     <a:lstStyle/>
                     <a:p>
                       <a:pPr algn="r">
-                        <a:defRPr sz="1250" b="1">
+                        <a:defRPr sz="1250" b="0">
                           <a:solidFill>
-                            <a:srgbClr val="1C1C1A"/>
+                            <a:srgbClr val="6B6A64"/>
                           </a:solidFill>
                         </a:defRPr>
                       </a:pPr>
                       <a:r>
-                        <a:t>—</a:t>
+                        <a:t>2017–2023</a:t>
                       </a:r>
                     </a:p>
                   </a:txBody>
@@ -9050,14 +9050,14 @@
                     <a:lstStyle/>
                     <a:p>
                       <a:pPr algn="r">
-                        <a:defRPr sz="1250" b="1">
+                        <a:defRPr sz="1250" b="0">
                           <a:solidFill>
-                            <a:srgbClr val="1C1C1A"/>
+                            <a:srgbClr val="6B6A64"/>
                           </a:solidFill>
                         </a:defRPr>
                       </a:pPr>
                       <a:r>
-                        <a:t>—</a:t>
+                        <a:t>1.9 mill.</a:t>
                       </a:r>
                     </a:p>
                   </a:txBody>
@@ -9071,14 +9071,14 @@
                     <a:lstStyle/>
                     <a:p>
                       <a:pPr algn="r">
-                        <a:defRPr sz="1250" b="1">
+                        <a:defRPr sz="1250" b="0">
                           <a:solidFill>
-                            <a:srgbClr val="1C1C1A"/>
+                            <a:srgbClr val="6B6A64"/>
                           </a:solidFill>
                         </a:defRPr>
                       </a:pPr>
                       <a:r>
-                        <a:t>no entregados</a:t>
+                        <a:t>179 767</a:t>
                       </a:r>
                     </a:p>
                   </a:txBody>
@@ -9390,6 +9390,44 @@
               <a:t>Guatemala publica sus datos sin el detalle de oficio ni de rama, así que no entra en los cortes finos. No se arregla con otra encuesta.</a:t>
             </a:r>
           </a:p>
+          <a:p>
+            <a:pPr algn="l">
+              <a:lnSpc>
+                <a:spcPct val="125000"/>
+              </a:lnSpc>
+              <a:spcAft>
+                <a:spcPts val="600"/>
+              </a:spcAft>
+            </a:pPr>
+            <a:r>
+              <a:rPr sz="1250" b="0">
+                <a:solidFill>
+                  <a:srgbClr val="1C1C1A"/>
+                </a:solidFill>
+                <a:latin typeface="Calibri"/>
+              </a:rPr>
+              <a:t/>
+            </a:r>
+          </a:p>
+          <a:p>
+            <a:pPr algn="l">
+              <a:lnSpc>
+                <a:spcPct val="125000"/>
+              </a:lnSpc>
+              <a:spcAft>
+                <a:spcPts val="600"/>
+              </a:spcAft>
+            </a:pPr>
+            <a:r>
+              <a:rPr sz="1250" b="0">
+                <a:solidFill>
+                  <a:srgbClr val="1C1C1A"/>
+                </a:solidFill>
+                <a:latin typeface="Calibri"/>
+              </a:rPr>
+              <a:t>Panamá entró completo, pero casi no tiene estos sectores: es una economía de servicios.</a:t>
+            </a:r>
+          </a:p>
         </p:txBody>
       </p:sp>
       <p:cxnSp>
@@ -9832,8 +9870,8 @@
         </p:blipFill>
         <p:spPr>
           <a:xfrm>
-            <a:off x="2742118" y="1691640"/>
-            <a:ext cx="6707458" cy="4343400"/>
+            <a:off x="2815803" y="1691640"/>
+            <a:ext cx="6560088" cy="4343400"/>
           </a:xfrm>
           <a:prstGeom prst="rect">
             <a:avLst/>
@@ -10518,7 +10556,7 @@
                 </a:solidFill>
                 <a:latin typeface="Calibri"/>
               </a:rPr>
-              <a:t>CAPARD son aquí cuatro países: Costa Rica, El Salvador, Honduras y República Dominicana. Guatemala no aparece porque su encuesta registra la ocupación con menos detalle; Nicaragua y Panamá no están disponibles.</a:t>
+              <a:t>CAPARD son aquí cuatro países con ocupación a cuatro dígitos: Costa Rica, El Salvador, Honduras y República Dominicana. Guatemala no aparece porque su encuesta registra la ocupación con menos detalle; Nicaragua y Panamá no están disponibles.</a:t>
             </a:r>
           </a:p>
         </p:txBody>

</xml_diff>

<commit_message>
Serie larga de Mexico y Honduras pre-covid
</commit_message>
<xml_diff>
--- a/Presentacion_CID_IA_Sectores.pptx
+++ b/Presentacion_CID_IA_Sectores.pptx
@@ -9625,8 +9625,8 @@
         </p:blipFill>
         <p:spPr>
           <a:xfrm>
-            <a:off x="2772608" y="1691640"/>
-            <a:ext cx="6646478" cy="3200400"/>
+            <a:off x="2173053" y="1691640"/>
+            <a:ext cx="7845588" cy="3200399"/>
           </a:xfrm>
           <a:prstGeom prst="rect">
             <a:avLst/>

</xml_diff>